<commit_message>
COO session sync: OAuth findings, tool activation research, doc updates
Major findings: OAuth invalid_grant is Claude platform bug (#21333).
Tool activation baseline is 20%, improves to 84% with proper
descriptions (4-6 sentences, explicit triggers, negative capability).
Blueprint updated: calibration → compounding architecture.
All investor docs updated for 5-tool architecture.

Co-Authored-By: Claude Opus 4.6 (1M context) <noreply@anthropic.com>
</commit_message>
<xml_diff>
--- a/docs/Deck.pptx
+++ b/docs/Deck.pptx
@@ -972,9 +972,9 @@
             <a:r>
               <a:rPr lang="en-US" dirty="0"/>
               <a:t>Be maximally honest.
-Three layers: (1) Hidden implementation — extraction logic is server-side, a competitor cannot inspect it. (2) Per-user calibration — encrypted parameters compound per-Author over time, the therapist moat. (3) Non-obvious question — the problem is not trivially obvious to identify.
-None is a wall. Together they are a meaningful head start.
-Additional moats if they ask: Library for Labs network effects, tribe identity (kin mechanic creates social lock-in), structural unkillability ($400/mo burn means the company literally cannot die).
+Defensibility is a cost gradient, not a wall. Primary force: the lock-in disincentive — labs won’t build the thing that makes it easy to leave. Regulation and breach liability reinforce it. On top: (1) Hidden implementation — extraction logic is server-side, a competitor cannot inspect it. (2) Per-user feedback log compounding — the therapist moat, unstructured signal that appreciates with model quality. (3) Non-obvious question — the problem is not trivially obvious to identify.
+None is a wall. Together they create a position genuinely hard for labs to occupy.
+Additional moats if they ask: Library for Labs network effects, tribe identity (kin mechanic creates social lock-in), structural unkillability ($500/mo burn means the company literally cannot die).
 If they ask what stops Apple: nothing, structurally. Giants do not create categories. They enter proven ones. And if Apple builds it — that IS the exit thesis. Acquisition not competition.
 The honesty IS the pitch. If you hedge here, they trust nothing else.</a:t>
             </a:r>
@@ -1161,12 +1161,12 @@
           <a:p>
             <a:r>
               <a:rPr lang="en-US" dirty="0"/>
-              <a:t>$50K at 5% implies a $1M pre-money valuation. Completely standard for pre-revenue with live product.
+              <a:t>$50K at ~1% implies a $5M pre-money valuation. Conservative relative to comps: Delphi ($18.7M Series A, Sequoia), Mem0 ($24M, YC), Uare.ai ($10.3M seed) — all building fragments of what Alexandria unifies. None has the full thesis.
 The MOM and IRR numbers are a function of the near-zero cost base, not optimistic projections.
-The 10x case assumes Alexandria is just a SaaS company with no dataset premium. Even the floor is 46x on a $50K check.
+The 10x case assumes Alexandria is just a SaaS company with no dataset premium. Even the floor is 9.1x on a $50K check.
 If they push on the 20x multiple: it assumes a strategic buyer paying a premium for the Library for Labs dataset and trust infrastructure. That is an assumption.
-The downside is not zero — it is 23x. The company is still profitable. There is no scenario where the investment goes to zero because the burn is so low.
-Why the raise is small: the company does not need the money. It runs on $400/month. The money is a buffer — it lets the founder stay in build mode without friction. The real value of the investment is partnership, not capital. The founder is choosing who to have on the cap table, not filling a round.
+The downside is not zero — it is 4.6x. The company is still profitable. There is no scenario where the investment goes to zero because the burn is so low.
+Why the raise is small: the company does not need the money. It runs on $500/month. The money is a buffer — it lets the founder stay in build mode without friction. The real value of the investment is partnership, not capital. The founder is choosing who to have on the cap table, not filling a round.
 Three return paths: subscription growth, Library for Labs B2B, strategic exit.</a:t>
             </a:r>
             <a:endParaRPr lang="en-US" dirty="0"/>
@@ -1349,11 +1349,11 @@
             <a:r>
               <a:rPr lang="en-US" dirty="0"/>
               <a:t>State the ask clearly. Do not apologise for it.
-The company does not need the money. It runs on $400 a month. The founder builds regardless.
+The company does not need the money. It runs on $500 a month. The founder builds regardless.
 What $50K goes to: roughly half to brand building (ads, events, merch, community presence — the fuel that gets the kin mechanic flywheel started), and half to founder buffer (SF is tight at $280/month, rent-free does not last forever, this removes friction so the founder focuses on building). Both are real, both are specific.
 The kin mechanic is the distribution engine, but engines need fuel. The 25 founding seeds need to come from somewhere. Brand presence creates the top-of-funnel that the kin mechanic then compounds. Near-zero marginal CAC once the flywheel is turning, but modest upfront spend to start and sustain it.
-The real value of the investment is partnership. The founder is choosing who to have on the cap table, not filling a round. This is the cheapest entry point that will ever exist into a category with zero competitors.
-Every AI investor is spreading bets across crowded categories. Cognitive identity infrastructure has zero competitors. Most AI investments get obsoleted by the next model release. Alexandria is structurally different \u2014 the value is in the data and methodology, not the model capability.
+The real value of the investment is partnership. The founder is choosing who to have on the cap table, not filling a round. This is the cheapest entry point that will ever exist into a category where no one is building the full stack.
+Every AI investor is spreading bets across crowded categories. Cognitive identity infrastructure has no full-stack competitor. Adjacent companies have raised $60M+ from Sequoia, YC, and a16z. Most AI investments get obsoleted by the next model release. Alexandria is structurally different \u2014 the value is in the data and methodology, not the model capability.
 If they want to negotiate terms: be open. But be clear about selectivity. Limited spots. The founder does not need the money.</a:t>
             </a:r>
             <a:endParaRPr lang="en-US" dirty="0"/>
@@ -2493,7 +2493,7 @@
                 <a:ea typeface="Georgia" pitchFamily="34" charset="-122"/>
                 <a:cs typeface="Georgia" pitchFamily="34" charset="-120"/>
               </a:rPr>
-              <a:t>$400/month total burn</a:t>
+              <a:t>$500/month total burn</a:t>
             </a:r>
             <a:endParaRPr lang="en-US" sz="3600" dirty="0"/>
           </a:p>
@@ -2642,7 +2642,7 @@
                 <a:ea typeface="Georgia" pitchFamily="34" charset="-122"/>
                 <a:cs typeface="Georgia" pitchFamily="34" charset="-120"/>
               </a:rPr>
-              <a:t>$50K at 5% equity</a:t>
+              <a:t>$50K at ~1% equity</a:t>
             </a:r>
             <a:endParaRPr lang="en-US" sz="3600" dirty="0"/>
           </a:p>
@@ -2681,7 +2681,7 @@
                 <a:ea typeface="Calibri" pitchFamily="34" charset="-122"/>
                 <a:cs typeface="Calibri" pitchFamily="34" charset="-120"/>
               </a:rPr>
-              <a:t>10x ARR:  46x MOM  ·  115% IRR</a:t>
+              <a:t>10x ARR:  9.1x MOM  ·  56% IRR</a:t>
             </a:r>
             <a:endParaRPr lang="en-US" sz="1600" dirty="0"/>
           </a:p>
@@ -2698,7 +2698,7 @@
                 <a:ea typeface="Calibri" pitchFamily="34" charset="-122"/>
                 <a:cs typeface="Calibri" pitchFamily="34" charset="-120"/>
               </a:rPr>
-              <a:t>15x ARR:  69x MOM  ·  133% IRR</a:t>
+              <a:t>15x ARR:  13.7x MOM  ·  69% IRR</a:t>
             </a:r>
             <a:endParaRPr lang="en-US" sz="1600" dirty="0"/>
           </a:p>
@@ -2715,7 +2715,7 @@
                 <a:ea typeface="Calibri" pitchFamily="34" charset="-122"/>
                 <a:cs typeface="Calibri" pitchFamily="34" charset="-120"/>
               </a:rPr>
-              <a:t>20x ARR:  92x MOM  ·  147% IRR</a:t>
+              <a:t>20x ARR:  18.2x MOM  ·  79% IRR</a:t>
             </a:r>
             <a:endParaRPr lang="en-US" sz="1600" dirty="0"/>
           </a:p>
@@ -2754,7 +2754,7 @@
                 <a:ea typeface="Calibri" pitchFamily="34" charset="-122"/>
                 <a:cs typeface="Calibri" pitchFamily="34" charset="-120"/>
               </a:rPr>
-              <a:t>Downside — half the base case:  23x MOM.  Still profitable.</a:t>
+              <a:t>Downside — half the base case:  4.6x MOM.  Still profitable.</a:t>
             </a:r>
             <a:endParaRPr lang="en-US" sz="1400" dirty="0"/>
           </a:p>
@@ -2974,7 +2974,7 @@
                 <a:ea typeface="Calibri" pitchFamily="34" charset="-122"/>
                 <a:cs typeface="Calibri" pitchFamily="34" charset="-120"/>
               </a:rPr>
-              <a:t>$50K at 5% equity.</a:t>
+              <a:t>$50K at ~1% equity.</a:t>
             </a:r>
             <a:endParaRPr lang="en-US" sz="1600" dirty="0"/>
           </a:p>

</xml_diff>